<commit_message>
Fix current-price recency and sync final submission deck
</commit_message>
<xml_diff>
--- a/TailDaam_Submission.pptx
+++ b/TailDaam_Submission.pptx
@@ -2078,9 +2078,18 @@
           <a:bodyPr wrap="square" lIns="0" tIns="0" rIns="0" bIns="0" rtlCol="0" anchor="ctr"/>
           <a:lstStyle/>
           <a:p>
-            <a:r>
-              <a:t>TailDaam — Pakistan fuel prices, with receipts</a:t>
-            </a:r>
+            <a:pPr algn="l" indent="0" marL="0">
+              <a:buNone/>
+            </a:pPr>
+            <a:r>
+              <a:rPr lang="en-US" sz="3000" b="1" dirty="0">
+                <a:solidFill>
+                  <a:schemeClr val="tx2"/>
+                </a:solidFill>
+              </a:rPr>
+              <a:t>TailDaam: Fuel Prices, With Receipts</a:t>
+            </a:r>
+            <a:endParaRPr lang="en-US" sz="3000" dirty="0"/>
           </a:p>
         </p:txBody>
       </p:sp>
@@ -2107,36 +2116,21 @@
           <a:bodyPr wrap="square" lIns="0" tIns="0" rIns="0" bIns="0" rtlCol="0" anchor="ctr"/>
           <a:lstStyle/>
           <a:p>
-            <a:r>
-              <a:t>TailDaam  |  Energy demand / Data Science Hackathon 2026</a:t>
-            </a:r>
-          </a:p>
-        </p:txBody>
-      </p:sp>
-      <p:pic>
-        <p:nvPicPr>
-          <p:cNvPr id="4" name="Picture 3" descr="mark.png"/>
-          <p:cNvPicPr>
-            <a:picLocks noChangeAspect="1"/>
-          </p:cNvPicPr>
-          <p:nvPr/>
-        </p:nvPicPr>
-        <p:blipFill>
-          <a:blip r:embed="rId3"/>
-          <a:stretch>
-            <a:fillRect/>
-          </a:stretch>
-        </p:blipFill>
-        <p:spPr>
-          <a:xfrm>
-            <a:off x="3657600" y="731520"/>
-            <a:ext cx="1097280" cy="1097280"/>
-          </a:xfrm>
-          <a:prstGeom prst="rect">
-            <a:avLst/>
-          </a:prstGeom>
-        </p:spPr>
-      </p:pic>
+            <a:pPr algn="l" indent="0" marL="0">
+              <a:buNone/>
+            </a:pPr>
+            <a:r>
+              <a:rPr lang="en-US" sz="1600" dirty="0">
+                <a:solidFill>
+                  <a:schemeClr val="tx1"/>
+                </a:solidFill>
+              </a:rPr>
+              <a:t>Danyal Abbas (solo)  |  Track: Energy demand</a:t>
+            </a:r>
+            <a:endParaRPr lang="en-US" sz="1600" dirty="0"/>
+          </a:p>
+        </p:txBody>
+      </p:sp>
     </p:spTree>
   </p:cSld>
   <p:clrMapOvr>
@@ -2185,9 +2179,18 @@
           <a:bodyPr wrap="square" lIns="0" tIns="0" rIns="0" bIns="0" rtlCol="0" anchor="ctr"/>
           <a:lstStyle/>
           <a:p>
-            <a:r>
+            <a:pPr algn="l" indent="0" marL="0">
+              <a:buNone/>
+            </a:pPr>
+            <a:r>
+              <a:rPr lang="en-US" sz="3200" b="1" dirty="0">
+                <a:solidFill>
+                  <a:schemeClr val="tx2"/>
+                </a:solidFill>
+              </a:rPr>
               <a:t>Problem Statement</a:t>
             </a:r>
+            <a:endParaRPr lang="en-US" sz="3200" dirty="0"/>
           </a:p>
         </p:txBody>
       </p:sp>
@@ -2212,10 +2215,6 @@
           </a:solidFill>
           <a:ln/>
         </p:spPr>
-        <p:txBody>
-          <a:bodyPr/>
-          <a:p/>
-        </p:txBody>
       </p:sp>
       <p:sp>
         <p:nvSpPr>
@@ -2274,9 +2273,18 @@
           <a:bodyPr wrap="square" lIns="0" tIns="0" rIns="0" bIns="0" rtlCol="0" anchor="t"/>
           <a:lstStyle/>
           <a:p>
-            <a:r>
-              <a:t>Pakistani petrol and diesel prices are administered at fortnightly reviews, but the evidence is scattered across weekly PBS reports, city-level annexes and global benchmark feeds. Most tools repeat a headline or generate an answer without showing where it came from.</a:t>
-            </a:r>
+            <a:pPr indent="0" marL="0">
+              <a:buNone/>
+            </a:pPr>
+            <a:r>
+              <a:rPr lang="en-US" sz="1800" dirty="0">
+                <a:solidFill>
+                  <a:schemeClr val="tx1"/>
+                </a:solidFill>
+              </a:rPr>
+              <a:t>OGRA resets petrol and diesel prices every fortnight, yet the evidence is scattered across PBS reports, city tables and global feeds. Claims about why prices moved are hard to verify, and nothing says “the data cannot answer that.”</a:t>
+            </a:r>
+            <a:endParaRPr lang="en-US" sz="1800" dirty="0"/>
           </a:p>
         </p:txBody>
       </p:sp>
@@ -2301,10 +2309,6 @@
           </a:solidFill>
           <a:ln/>
         </p:spPr>
-        <p:txBody>
-          <a:bodyPr/>
-          <a:p/>
-        </p:txBody>
       </p:sp>
       <p:sp>
         <p:nvSpPr>
@@ -2401,9 +2405,18 @@
           <a:bodyPr wrap="square" lIns="0" tIns="0" rIns="0" bIns="0" rtlCol="0" anchor="ctr"/>
           <a:lstStyle/>
           <a:p>
-            <a:r>
-              <a:t>Households, transport and industry, journalists, analysts and policymakers in Pakistan.</a:t>
-            </a:r>
+            <a:pPr indent="0" marL="0">
+              <a:buNone/>
+            </a:pPr>
+            <a:r>
+              <a:rPr lang="en-US" sz="1200" dirty="0">
+                <a:solidFill>
+                  <a:schemeClr val="accent6"/>
+                </a:solidFill>
+              </a:rPr>
+              <a:t>Households, transporters, small businesses</a:t>
+            </a:r>
+            <a:endParaRPr lang="en-US" sz="1200" dirty="0"/>
           </a:p>
         </p:txBody>
       </p:sp>
@@ -2428,10 +2441,6 @@
           </a:solidFill>
           <a:ln/>
         </p:spPr>
-        <p:txBody>
-          <a:bodyPr/>
-          <a:p/>
-        </p:txBody>
       </p:sp>
       <p:sp>
         <p:nvSpPr>
@@ -2528,9 +2537,18 @@
           <a:bodyPr wrap="square" lIns="0" tIns="0" rIns="0" bIns="0" rtlCol="0" anchor="ctr"/>
           <a:lstStyle/>
           <a:p>
-            <a:r>
-              <a:t>Fuel prices affect inflation, transport cost and import-bill risk. TailDaam covers 91,672 clean rows from 62 raw files.</a:t>
-            </a:r>
+            <a:pPr indent="0" marL="0">
+              <a:buNone/>
+            </a:pPr>
+            <a:r>
+              <a:rPr lang="en-US" sz="1200" dirty="0">
+                <a:solidFill>
+                  <a:schemeClr val="accent6"/>
+                </a:solidFill>
+              </a:rPr>
+              <a:t>Pakistan's most politically sensitive price</a:t>
+            </a:r>
+            <a:endParaRPr lang="en-US" sz="1200" dirty="0"/>
           </a:p>
         </p:txBody>
       </p:sp>
@@ -2555,10 +2573,6 @@
           </a:solidFill>
           <a:ln/>
         </p:spPr>
-        <p:txBody>
-          <a:bodyPr/>
-          <a:p/>
-        </p:txBody>
       </p:sp>
       <p:sp>
         <p:nvSpPr>
@@ -2655,9 +2669,18 @@
           <a:bodyPr wrap="square" lIns="0" tIns="0" rIns="0" bIns="0" rtlCol="0" anchor="ctr"/>
           <a:lstStyle/>
           <a:p>
-            <a:r>
-              <a:t>Build a governed fuel-price record, a baseline-beating volatility model, and a refusal-first cited insight agent.</a:t>
-            </a:r>
+            <a:pPr indent="0" marL="0">
+              <a:buNone/>
+            </a:pPr>
+            <a:r>
+              <a:rPr lang="en-US" sz="1200" dirty="0">
+                <a:solidFill>
+                  <a:schemeClr val="accent6"/>
+                </a:solidFill>
+              </a:rPr>
+              <a:t>Cited answers, or an honest refusal</a:t>
+            </a:r>
+            <a:endParaRPr lang="en-US" sz="1200" dirty="0"/>
           </a:p>
         </p:txBody>
       </p:sp>
@@ -2754,9 +2777,18 @@
           <a:bodyPr wrap="square" lIns="0" tIns="0" rIns="0" bIns="0" rtlCol="0" anchor="ctr"/>
           <a:lstStyle/>
           <a:p>
-            <a:r>
+            <a:pPr algn="l" indent="0" marL="0">
+              <a:buNone/>
+            </a:pPr>
+            <a:r>
+              <a:rPr lang="en-US" sz="3200" b="1" dirty="0">
+                <a:solidFill>
+                  <a:schemeClr val="tx2"/>
+                </a:solidFill>
+              </a:rPr>
               <a:t>Dataset Declaration</a:t>
             </a:r>
+            <a:endParaRPr lang="en-US" sz="3200" dirty="0"/>
           </a:p>
         </p:txBody>
       </p:sp>
@@ -2792,9 +2824,18 @@
                     <a:bodyPr/>
                     <a:lstStyle/>
                     <a:p>
+                      <a:pPr indent="0" marL="0">
+                        <a:buNone/>
+                      </a:pPr>
                       <a:r>
+                        <a:rPr lang="en-US" sz="1400" b="1" dirty="0">
+                          <a:solidFill>
+                            <a:schemeClr val="tx2"/>
+                          </a:solidFill>
+                        </a:rPr>
                         <a:t>Dataset name</a:t>
                       </a:r>
+                      <a:endParaRPr lang="en-US" sz="1400" dirty="0"/>
                     </a:p>
                   </a:txBody>
                   <a:tcPr marL="109728" marR="109728" marT="0" marB="0" anchor="ctr">
@@ -2844,9 +2885,18 @@
                     <a:bodyPr/>
                     <a:lstStyle/>
                     <a:p>
+                      <a:pPr indent="0" marL="0">
+                        <a:buNone/>
+                      </a:pPr>
                       <a:r>
-                        <a:t>TailDaam governed fuel-price warehouse</a:t>
+                        <a:rPr lang="en-US" sz="1200" dirty="0">
+                          <a:solidFill>
+                            <a:schemeClr val="accent6"/>
+                          </a:solidFill>
+                        </a:rPr>
+                        <a:t>TailDaam gold layer (PBS + EIA + World Bank)</a:t>
                       </a:r>
+                      <a:endParaRPr lang="en-US" sz="1200" dirty="0"/>
                     </a:p>
                   </a:txBody>
                   <a:tcPr marL="109728" marR="109728" marT="0" marB="0" anchor="ctr">
@@ -2895,9 +2945,18 @@
                     <a:bodyPr/>
                     <a:lstStyle/>
                     <a:p>
+                      <a:pPr indent="0" marL="0">
+                        <a:buNone/>
+                      </a:pPr>
                       <a:r>
+                        <a:rPr lang="en-US" sz="1400" b="1" dirty="0">
+                          <a:solidFill>
+                            <a:schemeClr val="tx2"/>
+                          </a:solidFill>
+                        </a:rPr>
                         <a:t>Source / link</a:t>
                       </a:r>
+                      <a:endParaRPr lang="en-US" sz="1400" dirty="0"/>
                     </a:p>
                   </a:txBody>
                   <a:tcPr marL="109728" marR="109728" marT="0" marB="0" anchor="ctr">
@@ -2947,9 +3006,18 @@
                     <a:bodyPr/>
                     <a:lstStyle/>
                     <a:p>
+                      <a:pPr indent="0" marL="0">
+                        <a:buNone/>
+                      </a:pPr>
                       <a:r>
-                        <a:t>PBS, U.S. EIA, World Bank Pink Sheet; github.com/DanyalAbbas/hack-insight</a:t>
+                        <a:rPr lang="en-US" sz="1200" dirty="0">
+                          <a:solidFill>
+                            <a:schemeClr val="accent6"/>
+                          </a:solidFill>
+                        </a:rPr>
+                        <a:t>PBS, EIA, World Bank (original publishers)</a:t>
                       </a:r>
+                      <a:endParaRPr lang="en-US" sz="1200" dirty="0"/>
                     </a:p>
                   </a:txBody>
                   <a:tcPr marL="109728" marR="109728" marT="0" marB="0" anchor="ctr">
@@ -2998,9 +3066,18 @@
                     <a:bodyPr/>
                     <a:lstStyle/>
                     <a:p>
+                      <a:pPr indent="0" marL="0">
+                        <a:buNone/>
+                      </a:pPr>
                       <a:r>
+                        <a:rPr lang="en-US" sz="1400" b="1" dirty="0">
+                          <a:solidFill>
+                            <a:schemeClr val="tx2"/>
+                          </a:solidFill>
+                        </a:rPr>
                         <a:t>Size</a:t>
                       </a:r>
+                      <a:endParaRPr lang="en-US" sz="1400" dirty="0"/>
                     </a:p>
                   </a:txBody>
                   <a:tcPr marL="109728" marR="109728" marT="0" marB="0" anchor="ctr">
@@ -3050,9 +3127,18 @@
                     <a:bodyPr/>
                     <a:lstStyle/>
                     <a:p>
+                      <a:pPr indent="0" marL="0">
+                        <a:buNone/>
+                      </a:pPr>
                       <a:r>
-                        <a:t>91,672 clean rows from 62 raw files; ~144 MB data directory</a:t>
+                        <a:rPr lang="en-US" sz="1200" dirty="0">
+                          <a:solidFill>
+                            <a:schemeClr val="accent6"/>
+                          </a:solidFill>
+                        </a:rPr>
+                        <a:t>91,672 clean rows from 62 raw files</a:t>
                       </a:r>
+                      <a:endParaRPr lang="en-US" sz="1200" dirty="0"/>
                     </a:p>
                   </a:txBody>
                   <a:tcPr marL="109728" marR="109728" marT="0" marB="0" anchor="ctr">
@@ -3101,9 +3187,18 @@
                     <a:bodyPr/>
                     <a:lstStyle/>
                     <a:p>
+                      <a:pPr indent="0" marL="0">
+                        <a:buNone/>
+                      </a:pPr>
                       <a:r>
+                        <a:rPr lang="en-US" sz="1400" b="1" dirty="0">
+                          <a:solidFill>
+                            <a:schemeClr val="tx2"/>
+                          </a:solidFill>
+                        </a:rPr>
                         <a:t>Time period</a:t>
                       </a:r>
+                      <a:endParaRPr lang="en-US" sz="1400" dirty="0"/>
                     </a:p>
                   </a:txBody>
                   <a:tcPr marL="109728" marR="109728" marT="0" marB="0" anchor="ctr">
@@ -3153,9 +3248,18 @@
                     <a:bodyPr/>
                     <a:lstStyle/>
                     <a:p>
+                      <a:pPr indent="0" marL="0">
+                        <a:buNone/>
+                      </a:pPr>
                       <a:r>
-                        <a:t>PBS weekly 2025-05 to 2026-10; city monthly Jan-Sep 2026; EIA daily; WB monthly</a:t>
+                        <a:rPr lang="en-US" sz="1200" dirty="0">
+                          <a:solidFill>
+                            <a:schemeClr val="accent6"/>
+                          </a:solidFill>
+                        </a:rPr>
+                        <a:t>PBS weekly May 2025-Oct 2026; city monthly Jan-Sep 2026; EIA/WB to Oct 2026</a:t>
                       </a:r>
+                      <a:endParaRPr lang="en-US" sz="1200" dirty="0"/>
                     </a:p>
                   </a:txBody>
                   <a:tcPr marL="109728" marR="109728" marT="0" marB="0" anchor="ctr">
@@ -3204,9 +3308,18 @@
                     <a:bodyPr/>
                     <a:lstStyle/>
                     <a:p>
+                      <a:pPr indent="0" marL="0">
+                        <a:buNone/>
+                      </a:pPr>
                       <a:r>
+                        <a:rPr lang="en-US" sz="1400" b="1" dirty="0">
+                          <a:solidFill>
+                            <a:schemeClr val="tx2"/>
+                          </a:solidFill>
+                        </a:rPr>
                         <a:t>Format &amp; license</a:t>
                       </a:r>
+                      <a:endParaRPr lang="en-US" sz="1400" dirty="0"/>
                     </a:p>
                   </a:txBody>
                   <a:tcPr marL="109728" marR="109728" marT="0" marB="0" anchor="ctr">
@@ -3256,9 +3369,18 @@
                     <a:bodyPr/>
                     <a:lstStyle/>
                     <a:p>
+                      <a:pPr indent="0" marL="0">
+                        <a:buNone/>
+                      </a:pPr>
                       <a:r>
-                        <a:t>CSV/Parquet; Government open publication, public domain, CC BY 4.0</a:t>
+                        <a:rPr lang="en-US" sz="1200" dirty="0">
+                          <a:solidFill>
+                            <a:schemeClr val="accent6"/>
+                          </a:solidFill>
+                        </a:rPr>
+                        <a:t>CSV; Govt open, public domain, CC BY 4.0</a:t>
                       </a:r>
+                      <a:endParaRPr lang="en-US" sz="1200" dirty="0"/>
                     </a:p>
                   </a:txBody>
                   <a:tcPr marL="109728" marR="109728" marT="0" marB="0" anchor="ctr">
@@ -3307,9 +3429,18 @@
                     <a:bodyPr/>
                     <a:lstStyle/>
                     <a:p>
+                      <a:pPr indent="0" marL="0">
+                        <a:buNone/>
+                      </a:pPr>
                       <a:r>
+                        <a:rPr lang="en-US" sz="1400" b="1" dirty="0">
+                          <a:solidFill>
+                            <a:schemeClr val="tx2"/>
+                          </a:solidFill>
+                        </a:rPr>
                         <a:t>Key features / target</a:t>
                       </a:r>
+                      <a:endParaRPr lang="en-US" sz="1400" dirty="0"/>
                     </a:p>
                   </a:txBody>
                   <a:tcPr marL="109728" marR="109728" marT="0" marB="0" anchor="ctr">
@@ -3359,9 +3490,18 @@
                     <a:bodyPr/>
                     <a:lstStyle/>
                     <a:p>
+                      <a:pPr indent="0" marL="0">
+                        <a:buNone/>
+                      </a:pPr>
                       <a:r>
-                        <a:t>Petrol/HSD prices by week and city; model target: next-month Brent realised volatility</a:t>
+                        <a:rPr lang="en-US" sz="1200" dirty="0">
+                          <a:solidFill>
+                            <a:schemeClr val="accent6"/>
+                          </a:solidFill>
+                        </a:rPr>
+                        <a:t>Target: next-month Brent volatility (HAR features)</a:t>
                       </a:r>
+                      <a:endParaRPr lang="en-US" sz="1200" dirty="0"/>
                     </a:p>
                   </a:txBody>
                   <a:tcPr marL="109728" marR="109728" marT="0" marB="0" anchor="ctr">
@@ -3429,10 +3569,6 @@
           </a:solidFill>
           <a:ln/>
         </p:spPr>
-        <p:txBody>
-          <a:bodyPr/>
-          <a:p/>
-        </p:txBody>
       </p:sp>
       <p:sp>
         <p:nvSpPr>
@@ -3444,33 +3580,6 @@
           <a:xfrm>
             <a:off x="6217920" y="1298448"/>
             <a:ext cx="2468880" cy="502920"/>
-          </a:xfrm>
-          <a:prstGeom prst="rect">
-            <a:avLst/>
-          </a:prstGeom>
-          <a:noFill/>
-          <a:ln/>
-        </p:spPr>
-        <p:txBody>
-          <a:bodyPr wrap="square" lIns="0" tIns="0" rIns="0" bIns="0" rtlCol="0" anchor="ctr"/>
-          <a:lstStyle/>
-          <a:p>
-            <a:r>
-              <a:t>91,672</a:t>
-            </a:r>
-          </a:p>
-        </p:txBody>
-      </p:sp>
-      <p:sp>
-        <p:nvSpPr>
-          <p:cNvPr id="6" name="Text 3"/>
-          <p:cNvSpPr txBox="1"/>
-          <p:nvPr/>
-        </p:nvSpPr>
-        <p:spPr>
-          <a:xfrm>
-            <a:off x="6217920" y="1828800"/>
-            <a:ext cx="2468880" cy="274320"/>
           </a:xfrm>
           <a:prstGeom prst="rect">
             <a:avLst/>
@@ -3486,12 +3595,48 @@
               <a:buNone/>
             </a:pPr>
             <a:r>
+              <a:rPr lang="en-US" sz="2800" b="1" dirty="0">
+                <a:solidFill>
+                  <a:schemeClr val="bg1"/>
+                </a:solidFill>
+              </a:rPr>
+              <a:t>91,672</a:t>
+            </a:r>
+            <a:endParaRPr lang="en-US" sz="2800" dirty="0"/>
+          </a:p>
+        </p:txBody>
+      </p:sp>
+      <p:sp>
+        <p:nvSpPr>
+          <p:cNvPr id="6" name="Text 3"/>
+          <p:cNvSpPr txBox="1"/>
+          <p:nvPr/>
+        </p:nvSpPr>
+        <p:spPr>
+          <a:xfrm>
+            <a:off x="6217920" y="1828800"/>
+            <a:ext cx="2468880" cy="274320"/>
+          </a:xfrm>
+          <a:prstGeom prst="rect">
+            <a:avLst/>
+          </a:prstGeom>
+          <a:noFill/>
+          <a:ln/>
+        </p:spPr>
+        <p:txBody>
+          <a:bodyPr wrap="square" lIns="0" tIns="0" rIns="0" bIns="0" rtlCol="0" anchor="ctr"/>
+          <a:lstStyle/>
+          <a:p>
+            <a:pPr algn="ctr" indent="0" marL="0">
+              <a:buNone/>
+            </a:pPr>
+            <a:r>
               <a:rPr lang="en-US" sz="1200" dirty="0">
                 <a:solidFill>
                   <a:schemeClr val="accent4"/>
                 </a:solidFill>
               </a:rPr>
-              <a:t>Rows / records</a:t>
+              <a:t>Clean rows</a:t>
             </a:r>
             <a:endParaRPr lang="en-US" sz="1200" dirty="0"/>
           </a:p>
@@ -3518,10 +3663,6 @@
           </a:solidFill>
           <a:ln/>
         </p:spPr>
-        <p:txBody>
-          <a:bodyPr/>
-          <a:p/>
-        </p:txBody>
       </p:sp>
       <p:sp>
         <p:nvSpPr>
@@ -3533,33 +3674,6 @@
           <a:xfrm>
             <a:off x="6217920" y="2441448"/>
             <a:ext cx="2468880" cy="502920"/>
-          </a:xfrm>
-          <a:prstGeom prst="rect">
-            <a:avLst/>
-          </a:prstGeom>
-          <a:noFill/>
-          <a:ln/>
-        </p:spPr>
-        <p:txBody>
-          <a:bodyPr wrap="square" lIns="0" tIns="0" rIns="0" bIns="0" rtlCol="0" anchor="ctr"/>
-          <a:lstStyle/>
-          <a:p>
-            <a:r>
-              <a:t>12+</a:t>
-            </a:r>
-          </a:p>
-        </p:txBody>
-      </p:sp>
-      <p:sp>
-        <p:nvSpPr>
-          <p:cNvPr id="9" name="Text 6"/>
-          <p:cNvSpPr txBox="1"/>
-          <p:nvPr/>
-        </p:nvSpPr>
-        <p:spPr>
-          <a:xfrm>
-            <a:off x="6217920" y="2971800"/>
-            <a:ext cx="2468880" cy="274320"/>
           </a:xfrm>
           <a:prstGeom prst="rect">
             <a:avLst/>
@@ -3575,12 +3689,48 @@
               <a:buNone/>
             </a:pPr>
             <a:r>
+              <a:rPr lang="en-US" sz="2800" b="1" dirty="0">
+                <a:solidFill>
+                  <a:schemeClr val="bg1"/>
+                </a:solidFill>
+              </a:rPr>
+              <a:t>62</a:t>
+            </a:r>
+            <a:endParaRPr lang="en-US" sz="2800" dirty="0"/>
+          </a:p>
+        </p:txBody>
+      </p:sp>
+      <p:sp>
+        <p:nvSpPr>
+          <p:cNvPr id="9" name="Text 6"/>
+          <p:cNvSpPr txBox="1"/>
+          <p:nvPr/>
+        </p:nvSpPr>
+        <p:spPr>
+          <a:xfrm>
+            <a:off x="6217920" y="2971800"/>
+            <a:ext cx="2468880" cy="274320"/>
+          </a:xfrm>
+          <a:prstGeom prst="rect">
+            <a:avLst/>
+          </a:prstGeom>
+          <a:noFill/>
+          <a:ln/>
+        </p:spPr>
+        <p:txBody>
+          <a:bodyPr wrap="square" lIns="0" tIns="0" rIns="0" bIns="0" rtlCol="0" anchor="ctr"/>
+          <a:lstStyle/>
+          <a:p>
+            <a:pPr algn="ctr" indent="0" marL="0">
+              <a:buNone/>
+            </a:pPr>
+            <a:r>
               <a:rPr lang="en-US" sz="1200" dirty="0">
                 <a:solidFill>
                   <a:schemeClr val="accent4"/>
                 </a:solidFill>
               </a:rPr>
-              <a:t>Columns / features</a:t>
+              <a:t>Raw source files</a:t>
             </a:r>
             <a:endParaRPr lang="en-US" sz="1200" dirty="0"/>
           </a:p>
@@ -3607,10 +3757,6 @@
           </a:solidFill>
           <a:ln/>
         </p:spPr>
-        <p:txBody>
-          <a:bodyPr/>
-          <a:p/>
-        </p:txBody>
       </p:sp>
       <p:sp>
         <p:nvSpPr>
@@ -3622,33 +3768,6 @@
           <a:xfrm>
             <a:off x="6217920" y="3584448"/>
             <a:ext cx="2468880" cy="502920"/>
-          </a:xfrm>
-          <a:prstGeom prst="rect">
-            <a:avLst/>
-          </a:prstGeom>
-          <a:noFill/>
-          <a:ln/>
-        </p:spPr>
-        <p:txBody>
-          <a:bodyPr wrap="square" lIns="0" tIns="0" rIns="0" bIns="0" rtlCol="0" anchor="ctr"/>
-          <a:lstStyle/>
-          <a:p>
-            <a:r>
-              <a:t>144 MB</a:t>
-            </a:r>
-          </a:p>
-        </p:txBody>
-      </p:sp>
-      <p:sp>
-        <p:nvSpPr>
-          <p:cNvPr id="12" name="Text 9"/>
-          <p:cNvSpPr txBox="1"/>
-          <p:nvPr/>
-        </p:nvSpPr>
-        <p:spPr>
-          <a:xfrm>
-            <a:off x="6217920" y="4114800"/>
-            <a:ext cx="2468880" cy="274320"/>
           </a:xfrm>
           <a:prstGeom prst="rect">
             <a:avLst/>
@@ -3664,12 +3783,48 @@
               <a:buNone/>
             </a:pPr>
             <a:r>
+              <a:rPr lang="en-US" sz="2800" b="1" dirty="0">
+                <a:solidFill>
+                  <a:schemeClr val="bg1"/>
+                </a:solidFill>
+              </a:rPr>
+              <a:t>3</a:t>
+            </a:r>
+            <a:endParaRPr lang="en-US" sz="2800" dirty="0"/>
+          </a:p>
+        </p:txBody>
+      </p:sp>
+      <p:sp>
+        <p:nvSpPr>
+          <p:cNvPr id="12" name="Text 9"/>
+          <p:cNvSpPr txBox="1"/>
+          <p:nvPr/>
+        </p:nvSpPr>
+        <p:spPr>
+          <a:xfrm>
+            <a:off x="6217920" y="4114800"/>
+            <a:ext cx="2468880" cy="274320"/>
+          </a:xfrm>
+          <a:prstGeom prst="rect">
+            <a:avLst/>
+          </a:prstGeom>
+          <a:noFill/>
+          <a:ln/>
+        </p:spPr>
+        <p:txBody>
+          <a:bodyPr wrap="square" lIns="0" tIns="0" rIns="0" bIns="0" rtlCol="0" anchor="ctr"/>
+          <a:lstStyle/>
+          <a:p>
+            <a:pPr algn="ctr" indent="0" marL="0">
+              <a:buNone/>
+            </a:pPr>
+            <a:r>
               <a:rPr lang="en-US" sz="1200" dirty="0">
                 <a:solidFill>
                   <a:schemeClr val="accent4"/>
                 </a:solidFill>
               </a:rPr>
-              <a:t>Dataset size</a:t>
+              <a:t>Independent publishers</a:t>
             </a:r>
             <a:endParaRPr lang="en-US" sz="1200" dirty="0"/>
           </a:p>
@@ -3768,9 +3923,18 @@
           <a:bodyPr wrap="square" lIns="0" tIns="0" rIns="0" bIns="0" rtlCol="0" anchor="ctr"/>
           <a:lstStyle/>
           <a:p>
-            <a:r>
+            <a:pPr algn="l" indent="0" marL="0">
+              <a:buNone/>
+            </a:pPr>
+            <a:r>
+              <a:rPr lang="en-US" sz="3200" b="1" dirty="0">
+                <a:solidFill>
+                  <a:schemeClr val="tx2"/>
+                </a:solidFill>
+              </a:rPr>
               <a:t>Pipeline Used</a:t>
             </a:r>
+            <a:endParaRPr lang="en-US" sz="3200" dirty="0"/>
           </a:p>
         </p:txBody>
       </p:sp>
@@ -3795,10 +3959,6 @@
           </a:solidFill>
           <a:ln/>
         </p:spPr>
-        <p:txBody>
-          <a:bodyPr/>
-          <a:p/>
-        </p:txBody>
       </p:sp>
       <p:sp>
         <p:nvSpPr>
@@ -3868,7 +4028,7 @@
                   <a:schemeClr val="tx2"/>
                 </a:solidFill>
               </a:rPr>
-              <a:t>Data Collection</a:t>
+              <a:t>Acquire</a:t>
             </a:r>
             <a:endParaRPr lang="en-US" sz="1400" dirty="0"/>
           </a:p>
@@ -3895,9 +4055,18 @@
           <a:bodyPr wrap="square" lIns="0" tIns="0" rIns="0" bIns="0" rtlCol="0" anchor="t"/>
           <a:lstStyle/>
           <a:p>
-            <a:r>
-              <a:t>PBS 41 weekly + 9 city annexes, EIA 11 daily series, World Bank Pink Sheet</a:t>
-            </a:r>
+            <a:pPr algn="ctr" indent="0" marL="0">
+              <a:buNone/>
+            </a:pPr>
+            <a:r>
+              <a:rPr lang="en-US" sz="1200" dirty="0">
+                <a:solidFill>
+                  <a:schemeClr val="accent6"/>
+                </a:solidFill>
+              </a:rPr>
+              <a:t>PBS, EIA, World Bank; SHA-256 manifest</a:t>
+            </a:r>
+            <a:endParaRPr lang="en-US" sz="1200" dirty="0"/>
           </a:p>
         </p:txBody>
       </p:sp>
@@ -3920,10 +4089,6 @@
           </a:solidFill>
           <a:ln/>
         </p:spPr>
-        <p:txBody>
-          <a:bodyPr/>
-          <a:p/>
-        </p:txBody>
       </p:sp>
       <p:sp>
         <p:nvSpPr>
@@ -3946,10 +4111,6 @@
           </a:solidFill>
           <a:ln/>
         </p:spPr>
-        <p:txBody>
-          <a:bodyPr/>
-          <a:p/>
-        </p:txBody>
       </p:sp>
       <p:sp>
         <p:nvSpPr>
@@ -4019,7 +4180,7 @@
                   <a:schemeClr val="tx2"/>
                 </a:solidFill>
               </a:rPr>
-              <a:t>Data Cleaning</a:t>
+              <a:t>Clean &amp; Quality</a:t>
             </a:r>
             <a:endParaRPr lang="en-US" sz="1400" dirty="0"/>
           </a:p>
@@ -4046,9 +4207,18 @@
           <a:bodyPr wrap="square" lIns="0" tIns="0" rIns="0" bIns="0" rtlCol="0" anchor="t"/>
           <a:lstStyle/>
           <a:p>
-            <a:r>
-              <a:t>Typed long tables with stable row IDs; no invented observations</a:t>
-            </a:r>
+            <a:pPr algn="ctr" indent="0" marL="0">
+              <a:buNone/>
+            </a:pPr>
+            <a:r>
+              <a:rPr lang="en-US" sz="1200" dirty="0">
+                <a:solidFill>
+                  <a:schemeClr val="accent6"/>
+                </a:solidFill>
+              </a:rPr>
+              <a:t>Typed tables; FIX / FLAG / FAIL log</a:t>
+            </a:r>
+            <a:endParaRPr lang="en-US" sz="1200" dirty="0"/>
           </a:p>
         </p:txBody>
       </p:sp>
@@ -4071,10 +4241,6 @@
           </a:solidFill>
           <a:ln/>
         </p:spPr>
-        <p:txBody>
-          <a:bodyPr/>
-          <a:p/>
-        </p:txBody>
       </p:sp>
       <p:sp>
         <p:nvSpPr>
@@ -4097,10 +4263,6 @@
           </a:solidFill>
           <a:ln/>
         </p:spPr>
-        <p:txBody>
-          <a:bodyPr/>
-          <a:p/>
-        </p:txBody>
       </p:sp>
       <p:sp>
         <p:nvSpPr>
@@ -4170,7 +4332,7 @@
                   <a:schemeClr val="tx2"/>
                 </a:solidFill>
               </a:rPr>
-              <a:t>Analysis / EDA</a:t>
+              <a:t>Gold Layer</a:t>
             </a:r>
             <a:endParaRPr lang="en-US" sz="1400" dirty="0"/>
           </a:p>
@@ -4197,9 +4359,18 @@
           <a:bodyPr wrap="square" lIns="0" tIns="0" rIns="0" bIns="0" rtlCol="0" anchor="t"/>
           <a:lstStyle/>
           <a:p>
-            <a:r>
-              <a:t>Quality agent: 14 rules, 1 fix, 4 flags</a:t>
-            </a:r>
+            <a:pPr algn="ctr" indent="0" marL="0">
+              <a:buNone/>
+            </a:pPr>
+            <a:r>
+              <a:rPr lang="en-US" sz="1200" dirty="0">
+                <a:solidFill>
+                  <a:schemeClr val="accent6"/>
+                </a:solidFill>
+              </a:rPr>
+              <a:t>Only quotable layer; row ids, citations</a:t>
+            </a:r>
+            <a:endParaRPr lang="en-US" sz="1200" dirty="0"/>
           </a:p>
         </p:txBody>
       </p:sp>
@@ -4222,10 +4393,6 @@
           </a:solidFill>
           <a:ln/>
         </p:spPr>
-        <p:txBody>
-          <a:bodyPr/>
-          <a:p/>
-        </p:txBody>
       </p:sp>
       <p:sp>
         <p:nvSpPr>
@@ -4248,10 +4415,6 @@
           </a:solidFill>
           <a:ln/>
         </p:spPr>
-        <p:txBody>
-          <a:bodyPr/>
-          <a:p/>
-        </p:txBody>
       </p:sp>
       <p:sp>
         <p:nvSpPr>
@@ -4321,7 +4484,7 @@
                   <a:schemeClr val="tx2"/>
                 </a:solidFill>
               </a:rPr>
-              <a:t>Modeling</a:t>
+              <a:t>Model</a:t>
             </a:r>
             <a:endParaRPr lang="en-US" sz="1400" dirty="0"/>
           </a:p>
@@ -4348,9 +4511,18 @@
           <a:bodyPr wrap="square" lIns="0" tIns="0" rIns="0" bIns="0" rtlCol="0" anchor="t"/>
           <a:lstStyle/>
           <a:p>
-            <a:r>
-              <a:t>HAR ridge vs persistence; 7.269% lower MAE; 89.25% interval coverage</a:t>
-            </a:r>
+            <a:pPr algn="ctr" indent="0" marL="0">
+              <a:buNone/>
+            </a:pPr>
+            <a:r>
+              <a:rPr lang="en-US" sz="1200" dirty="0">
+                <a:solidFill>
+                  <a:schemeClr val="accent6"/>
+                </a:solidFill>
+              </a:rPr>
+              <a:t>HAR ridge vs persistence baseline</a:t>
+            </a:r>
+            <a:endParaRPr lang="en-US" sz="1200" dirty="0"/>
           </a:p>
         </p:txBody>
       </p:sp>
@@ -4373,10 +4545,6 @@
           </a:solidFill>
           <a:ln/>
         </p:spPr>
-        <p:txBody>
-          <a:bodyPr/>
-          <a:p/>
-        </p:txBody>
       </p:sp>
       <p:sp>
         <p:nvSpPr>
@@ -4399,10 +4567,6 @@
           </a:solidFill>
           <a:ln/>
         </p:spPr>
-        <p:txBody>
-          <a:bodyPr/>
-          <a:p/>
-        </p:txBody>
       </p:sp>
       <p:sp>
         <p:nvSpPr>
@@ -4472,7 +4636,7 @@
                   <a:schemeClr val="tx2"/>
                 </a:solidFill>
               </a:rPr>
-              <a:t>Dashboard / App</a:t>
+              <a:t>Insight Agent</a:t>
             </a:r>
             <a:endParaRPr lang="en-US" sz="1400" dirty="0"/>
           </a:p>
@@ -4499,9 +4663,18 @@
           <a:bodyPr wrap="square" lIns="0" tIns="0" rIns="0" bIns="0" rtlCol="0" anchor="t"/>
           <a:lstStyle/>
           <a:p>
-            <a:r>
-              <a:t>FastAPI API + static Hugging Face Space; no login</a:t>
-            </a:r>
+            <a:pPr algn="ctr" indent="0" marL="0">
+              <a:buNone/>
+            </a:pPr>
+            <a:r>
+              <a:rPr lang="en-US" sz="1200" dirty="0">
+                <a:solidFill>
+                  <a:schemeClr val="accent6"/>
+                </a:solidFill>
+              </a:rPr>
+              <a:t>Cited answers or refusal; EN + Urdu</a:t>
+            </a:r>
+            <a:endParaRPr lang="en-US" sz="1200" dirty="0"/>
           </a:p>
         </p:txBody>
       </p:sp>
@@ -4526,10 +4699,6 @@
           </a:solidFill>
           <a:ln/>
         </p:spPr>
-        <p:txBody>
-          <a:bodyPr/>
-          <a:p/>
-        </p:txBody>
       </p:sp>
       <p:sp>
         <p:nvSpPr>
@@ -4552,9 +4721,18 @@
           <a:bodyPr wrap="square" lIns="0" tIns="0" rIns="0" bIns="0" rtlCol="0" anchor="ctr"/>
           <a:lstStyle/>
           <a:p>
-            <a:r>
-              <a:t>62 publisher files -&gt; 91,672 clean rows -&gt; cited fuel-price insights and Brent risk</a:t>
-            </a:r>
+            <a:pPr indent="0" marL="0">
+              <a:buNone/>
+            </a:pPr>
+            <a:r>
+              <a:rPr lang="en-US" sz="1400" dirty="0">
+                <a:solidFill>
+                  <a:schemeClr val="bg1"/>
+                </a:solidFill>
+              </a:rPr>
+              <a:t>Raw files in  -&gt;  cited prices, a volatility forecast, an agent that refuses</a:t>
+            </a:r>
+            <a:endParaRPr lang="en-US" sz="1400" dirty="0"/>
           </a:p>
         </p:txBody>
       </p:sp>
@@ -4651,9 +4829,18 @@
           <a:bodyPr wrap="square" lIns="0" tIns="0" rIns="0" bIns="0" rtlCol="0" anchor="ctr"/>
           <a:lstStyle/>
           <a:p>
-            <a:r>
+            <a:pPr algn="l" indent="0" marL="0">
+              <a:buNone/>
+            </a:pPr>
+            <a:r>
+              <a:rPr lang="en-US" sz="3200" b="1" dirty="0">
+                <a:solidFill>
+                  <a:schemeClr val="tx2"/>
+                </a:solidFill>
+              </a:rPr>
               <a:t>Pipeline Details &amp; Tools</a:t>
             </a:r>
+            <a:endParaRPr lang="en-US" sz="3200" dirty="0"/>
           </a:p>
         </p:txBody>
       </p:sp>
@@ -4803,9 +4990,18 @@
                     <a:bodyPr/>
                     <a:lstStyle/>
                     <a:p>
+                      <a:pPr indent="0" marL="0">
+                        <a:buNone/>
+                      </a:pPr>
                       <a:r>
+                        <a:rPr lang="en-US" sz="1400" b="1" dirty="0">
+                          <a:solidFill>
+                            <a:schemeClr val="tx2"/>
+                          </a:solidFill>
+                        </a:rPr>
                         <a:t>Collection</a:t>
                       </a:r>
+                      <a:endParaRPr lang="en-US" sz="1400" dirty="0"/>
                     </a:p>
                   </a:txBody>
                   <a:tcPr marL="109728" marR="109728" marT="0" marB="0" anchor="ctr">
@@ -4855,9 +5051,18 @@
                     <a:bodyPr/>
                     <a:lstStyle/>
                     <a:p>
+                      <a:pPr indent="0" marL="0">
+                        <a:buNone/>
+                      </a:pPr>
                       <a:r>
-                        <a:t>requests, PBS/EIA/WB endpoints</a:t>
+                        <a:rPr lang="en-US" sz="1200" dirty="0">
+                          <a:solidFill>
+                            <a:schemeClr val="accent6"/>
+                          </a:solidFill>
+                        </a:rPr>
+                        <a:t>Python, requests, SHA-256 manifest</a:t>
                       </a:r>
+                      <a:endParaRPr lang="en-US" sz="1200" dirty="0"/>
                     </a:p>
                   </a:txBody>
                   <a:tcPr marL="109728" marR="109728" marT="0" marB="0" anchor="ctr">
@@ -4904,9 +5109,18 @@
                     <a:bodyPr/>
                     <a:lstStyle/>
                     <a:p>
+                      <a:pPr indent="0" marL="0">
+                        <a:buNone/>
+                      </a:pPr>
                       <a:r>
-                        <a:t>Download and SHA-256 hash 62 original publisher files</a:t>
+                        <a:rPr lang="en-US" sz="1200" dirty="0">
+                          <a:solidFill>
+                            <a:schemeClr val="accent6"/>
+                          </a:solidFill>
+                        </a:rPr>
+                        <a:t>Downloads 62 raw files from PBS, EIA, World Bank; hashes each</a:t>
                       </a:r>
+                      <a:endParaRPr lang="en-US" sz="1200" dirty="0"/>
                     </a:p>
                   </a:txBody>
                   <a:tcPr marL="109728" marR="109728" marT="0" marB="0" anchor="ctr">
@@ -4955,9 +5169,18 @@
                     <a:bodyPr/>
                     <a:lstStyle/>
                     <a:p>
+                      <a:pPr indent="0" marL="0">
+                        <a:buNone/>
+                      </a:pPr>
                       <a:r>
-                        <a:t>Preprocessing</a:t>
+                        <a:rPr lang="en-US" sz="1400" b="1" dirty="0">
+                          <a:solidFill>
+                            <a:schemeClr val="tx2"/>
+                          </a:solidFill>
+                        </a:rPr>
+                        <a:t>Clean &amp; Quality</a:t>
                       </a:r>
+                      <a:endParaRPr lang="en-US" sz="1400" dirty="0"/>
                     </a:p>
                   </a:txBody>
                   <a:tcPr marL="109728" marR="109728" marT="0" marB="0" anchor="ctr">
@@ -5007,9 +5230,18 @@
                     <a:bodyPr/>
                     <a:lstStyle/>
                     <a:p>
+                      <a:pPr indent="0" marL="0">
+                        <a:buNone/>
+                      </a:pPr>
                       <a:r>
-                        <a:t>pandas, openpyxl, clean.py</a:t>
+                        <a:rPr lang="en-US" sz="1200" dirty="0">
+                          <a:solidFill>
+                            <a:schemeClr val="accent6"/>
+                          </a:solidFill>
+                        </a:rPr>
+                        <a:t>Python, rule-based quality agent</a:t>
                       </a:r>
+                      <a:endParaRPr lang="en-US" sz="1200" dirty="0"/>
                     </a:p>
                   </a:txBody>
                   <a:tcPr marL="109728" marR="109728" marT="0" marB="0" anchor="ctr">
@@ -5056,9 +5288,18 @@
                     <a:bodyPr/>
                     <a:lstStyle/>
                     <a:p>
+                      <a:pPr indent="0" marL="0">
+                        <a:buNone/>
+                      </a:pPr>
                       <a:r>
-                        <a:t>Normalise weekly, city and global tables; stable row IDs</a:t>
+                        <a:rPr lang="en-US" sz="1200" dirty="0">
+                          <a:solidFill>
+                            <a:schemeClr val="accent6"/>
+                          </a:solidFill>
+                        </a:rPr>
+                        <a:t>Typed tables; every decision logged, nothing invented</a:t>
                       </a:r>
+                      <a:endParaRPr lang="en-US" sz="1200" dirty="0"/>
                     </a:p>
                   </a:txBody>
                   <a:tcPr marL="109728" marR="109728" marT="0" marB="0" anchor="ctr">
@@ -5107,9 +5348,18 @@
                     <a:bodyPr/>
                     <a:lstStyle/>
                     <a:p>
+                      <a:pPr indent="0" marL="0">
+                        <a:buNone/>
+                      </a:pPr>
                       <a:r>
-                        <a:t>Analysis / EDA</a:t>
+                        <a:rPr lang="en-US" sz="1400" b="1" dirty="0">
+                          <a:solidFill>
+                            <a:schemeClr val="tx2"/>
+                          </a:solidFill>
+                        </a:rPr>
+                        <a:t>Gold layer</a:t>
                       </a:r>
+                      <a:endParaRPr lang="en-US" sz="1400" dirty="0"/>
                     </a:p>
                   </a:txBody>
                   <a:tcPr marL="109728" marR="109728" marT="0" marB="0" anchor="ctr">
@@ -5159,9 +5409,18 @@
                     <a:bodyPr/>
                     <a:lstStyle/>
                     <a:p>
+                      <a:pPr indent="0" marL="0">
+                        <a:buNone/>
+                      </a:pPr>
                       <a:r>
-                        <a:t>quality.py</a:t>
+                        <a:rPr lang="en-US" sz="1200" dirty="0">
+                          <a:solidFill>
+                            <a:schemeClr val="accent6"/>
+                          </a:solidFill>
+                        </a:rPr>
+                        <a:t>Row ids, citation registry</a:t>
                       </a:r>
+                      <a:endParaRPr lang="en-US" sz="1200" dirty="0"/>
                     </a:p>
                   </a:txBody>
                   <a:tcPr marL="109728" marR="109728" marT="0" marB="0" anchor="ctr">
@@ -5208,9 +5467,18 @@
                     <a:bodyPr/>
                     <a:lstStyle/>
                     <a:p>
+                      <a:pPr indent="0" marL="0">
+                        <a:buNone/>
+                      </a:pPr>
                       <a:r>
-                        <a:t>14 deterministic rules; every FIX/FLAG/FAIL logged</a:t>
+                        <a:rPr lang="en-US" sz="1200" dirty="0">
+                          <a:solidFill>
+                            <a:schemeClr val="accent6"/>
+                          </a:solidFill>
+                        </a:rPr>
+                        <a:t>The only layer the agent may quote; gaps stay gaps</a:t>
                       </a:r>
+                      <a:endParaRPr lang="en-US" sz="1200" dirty="0"/>
                     </a:p>
                   </a:txBody>
                   <a:tcPr marL="109728" marR="109728" marT="0" marB="0" anchor="ctr">
@@ -5259,9 +5527,18 @@
                     <a:bodyPr/>
                     <a:lstStyle/>
                     <a:p>
+                      <a:pPr indent="0" marL="0">
+                        <a:buNone/>
+                      </a:pPr>
                       <a:r>
+                        <a:rPr lang="en-US" sz="1400" b="1" dirty="0">
+                          <a:solidFill>
+                            <a:schemeClr val="tx2"/>
+                          </a:solidFill>
+                        </a:rPr>
                         <a:t>Modeling</a:t>
                       </a:r>
+                      <a:endParaRPr lang="en-US" sz="1400" dirty="0"/>
                     </a:p>
                   </a:txBody>
                   <a:tcPr marL="109728" marR="109728" marT="0" marB="0" anchor="ctr">
@@ -5311,9 +5588,18 @@
                     <a:bodyPr/>
                     <a:lstStyle/>
                     <a:p>
+                      <a:pPr indent="0" marL="0">
+                        <a:buNone/>
+                      </a:pPr>
                       <a:r>
-                        <a:t>scikit-learn, pandas</a:t>
+                        <a:rPr lang="en-US" sz="1200" dirty="0">
+                          <a:solidFill>
+                            <a:schemeClr val="accent6"/>
+                          </a:solidFill>
+                        </a:rPr>
+                        <a:t>HAR ridge (alpha = 10), pre-registered</a:t>
                       </a:r>
+                      <a:endParaRPr lang="en-US" sz="1200" dirty="0"/>
                     </a:p>
                   </a:txBody>
                   <a:tcPr marL="109728" marR="109728" marT="0" marB="0" anchor="ctr">
@@ -5360,9 +5646,18 @@
                     <a:bodyPr/>
                     <a:lstStyle/>
                     <a:p>
+                      <a:pPr indent="0" marL="0">
+                        <a:buNone/>
+                      </a:pPr>
                       <a:r>
-                        <a:t>HAR ridge vs persistence; 7.269% MAE win; 89.25% coverage</a:t>
+                        <a:rPr lang="en-US" sz="1200" dirty="0">
+                          <a:solidFill>
+                            <a:schemeClr val="accent6"/>
+                          </a:solidFill>
+                        </a:rPr>
+                        <a:t>Next-month Brent volatility: 7.27% lower MAE than baseline</a:t>
                       </a:r>
+                      <a:endParaRPr lang="en-US" sz="1200" dirty="0"/>
                     </a:p>
                   </a:txBody>
                   <a:tcPr marL="109728" marR="109728" marT="0" marB="0" anchor="ctr">
@@ -5411,9 +5706,18 @@
                     <a:bodyPr/>
                     <a:lstStyle/>
                     <a:p>
+                      <a:pPr indent="0" marL="0">
+                        <a:buNone/>
+                      </a:pPr>
                       <a:r>
+                        <a:rPr lang="en-US" sz="1400" b="1" dirty="0">
+                          <a:solidFill>
+                            <a:schemeClr val="tx2"/>
+                          </a:solidFill>
+                        </a:rPr>
                         <a:t>Dashboard / App</a:t>
                       </a:r>
+                      <a:endParaRPr lang="en-US" sz="1400" dirty="0"/>
                     </a:p>
                   </a:txBody>
                   <a:tcPr marL="109728" marR="109728" marT="0" marB="0" anchor="ctr">
@@ -5463,9 +5767,18 @@
                     <a:bodyPr/>
                     <a:lstStyle/>
                     <a:p>
+                      <a:pPr indent="0" marL="0">
+                        <a:buNone/>
+                      </a:pPr>
                       <a:r>
-                        <a:t>FastAPI, Prefect, Hugging Face</a:t>
+                        <a:rPr lang="en-US" sz="1200" dirty="0">
+                          <a:solidFill>
+                            <a:schemeClr val="accent6"/>
+                          </a:solidFill>
+                        </a:rPr>
+                        <a:t>FastAPI, Prefect, Chroma / TF-IDF</a:t>
                       </a:r>
+                      <a:endParaRPr lang="en-US" sz="1200" dirty="0"/>
                     </a:p>
                   </a:txBody>
                   <a:tcPr marL="109728" marR="109728" marT="0" marB="0" anchor="ctr">
@@ -5512,9 +5825,18 @@
                     <a:bodyPr/>
                     <a:lstStyle/>
                     <a:p>
+                      <a:pPr indent="0" marL="0">
+                        <a:buNone/>
+                      </a:pPr>
                       <a:r>
-                        <a:t>API, static UI, hourly pipeline, no login</a:t>
+                        <a:rPr lang="en-US" sz="1200" dirty="0">
+                          <a:solidFill>
+                            <a:schemeClr val="accent6"/>
+                          </a:solidFill>
+                        </a:rPr>
+                        <a:t>Hourly pipeline; EN + Urdu dashboard; refuses when unsupported</a:t>
                       </a:r>
+                      <a:endParaRPr lang="en-US" sz="1200" dirty="0"/>
                     </a:p>
                   </a:txBody>
                   <a:tcPr marL="109728" marR="109728" marT="0" marB="0" anchor="ctr">
@@ -5654,18 +5976,35 @@
           <a:bodyPr wrap="square" lIns="0" tIns="0" rIns="0" bIns="0" rtlCol="0" anchor="ctr"/>
           <a:lstStyle/>
           <a:p>
-            <a:r>
+            <a:pPr algn="l" indent="0" marL="0">
+              <a:buNone/>
+            </a:pPr>
+            <a:r>
+              <a:rPr lang="en-US" sz="3200" b="1" dirty="0">
+                <a:solidFill>
+                  <a:schemeClr val="tx2"/>
+                </a:solidFill>
+              </a:rPr>
               <a:t>Dashboard / App Views</a:t>
             </a:r>
-          </a:p>
-        </p:txBody>
-      </p:sp>
-      <p:sp>
-        <p:nvSpPr>
-          <p:cNvPr id="3" name="Screenshot 1"/>
-          <p:cNvSpPr/>
-          <p:nvPr/>
-        </p:nvSpPr>
+            <a:endParaRPr lang="en-US" sz="3200" dirty="0"/>
+          </a:p>
+        </p:txBody>
+      </p:sp>
+      <p:pic>
+        <p:nvPicPr>
+          <p:cNvPr id="30" name="Overview" descr="TailDaam dashboard screenshot: Overview"/>
+          <p:cNvPicPr>
+            <a:picLocks noChangeAspect="1"/>
+          </p:cNvPicPr>
+          <p:nvPr/>
+        </p:nvPicPr>
+        <p:blipFill>
+          <a:blip r:embed="rId3"/>
+          <a:stretch>
+            <a:fillRect/>
+          </a:stretch>
+        </p:blipFill>
         <p:spPr>
           <a:xfrm>
             <a:off x="457200" y="1188720"/>
@@ -5676,77 +6015,66 @@
               <a:gd name="adj" fmla="val 3125"/>
             </a:avLst>
           </a:prstGeom>
-          <a:solidFill>
-            <a:schemeClr val="bg2"/>
-          </a:solidFill>
           <a:ln w="19050">
             <a:solidFill>
               <a:schemeClr val="accent1"/>
             </a:solidFill>
-            <a:prstDash val="dash"/>
           </a:ln>
         </p:spPr>
-        <p:txBody>
-          <a:bodyPr/>
-          <a:p/>
-        </p:txBody>
-      </p:sp>
-      <p:sp>
-        <p:nvSpPr>
-          <p:cNvPr id="4" name="Text 2"/>
-          <p:cNvSpPr txBox="1"/>
-          <p:nvPr/>
-        </p:nvSpPr>
-        <p:spPr>
-          <a:xfrm>
-            <a:off x="457200" y="2331720"/>
-            <a:ext cx="4937760" cy="320040"/>
-          </a:xfrm>
-          <a:prstGeom prst="rect">
-            <a:avLst/>
-          </a:prstGeom>
-          <a:noFill/>
-          <a:ln/>
-        </p:spPr>
-        <p:txBody>
-          <a:bodyPr wrap="square" lIns="0" tIns="0" rIns="0" bIns="0" rtlCol="0" anchor="ctr"/>
-          <a:lstStyle/>
-          <a:p>
-            <a:r>
-              <a:t>Page 1 - Overview</a:t>
-            </a:r>
-          </a:p>
-        </p:txBody>
-      </p:sp>
-      <p:sp>
-        <p:nvSpPr>
-          <p:cNvPr id="5" name="Text 3"/>
-          <p:cNvSpPr txBox="1"/>
-          <p:nvPr/>
-        </p:nvSpPr>
-        <p:spPr>
-          <a:xfrm>
-            <a:off x="457200" y="2697480"/>
-            <a:ext cx="4937760" cy="274320"/>
-          </a:xfrm>
-          <a:prstGeom prst="rect">
-            <a:avLst/>
-          </a:prstGeom>
-          <a:noFill/>
-          <a:ln/>
-        </p:spPr>
-        <p:txBody>
-          <a:bodyPr wrap="square" lIns="0" tIns="0" rIns="0" bIns="0" rtlCol="0" anchor="ctr"/>
-          <a:lstStyle/>
-          <a:p/>
-        </p:txBody>
-      </p:sp>
-      <p:sp>
-        <p:nvSpPr>
-          <p:cNvPr id="6" name="Screenshot 2"/>
+      </p:pic>
+      <p:sp>
+        <p:nvSpPr>
+          <p:cNvPr id="31" name="Caption 31"/>
           <p:cNvSpPr/>
           <p:nvPr/>
         </p:nvSpPr>
+        <p:spPr>
+          <a:xfrm>
+            <a:off x="566928" y="3730752"/>
+            <a:ext cx="1737360" cy="274320"/>
+          </a:xfrm>
+          <a:prstGeom prst="roundRect">
+            <a:avLst>
+              <a:gd name="adj" fmla="val 30000"/>
+            </a:avLst>
+          </a:prstGeom>
+          <a:solidFill>
+            <a:schemeClr val="tx2"/>
+          </a:solidFill>
+          <a:ln>
+            <a:noFill/>
+          </a:ln>
+        </p:spPr>
+        <p:txBody>
+          <a:bodyPr wrap="square" lIns="91440" tIns="0" rIns="91440" bIns="0" rtlCol="0" anchor="ctr"/>
+          <a:lstStyle/>
+          <a:p>
+            <a:pPr algn="ctr"/>
+            <a:r>
+              <a:rPr lang="en-US" sz="1200" b="1" dirty="0">
+                <a:solidFill>
+                  <a:schemeClr val="bg1"/>
+                </a:solidFill>
+              </a:rPr>
+              <a:t>Page 1: Overview</a:t>
+            </a:r>
+          </a:p>
+        </p:txBody>
+      </p:sp>
+      <p:pic>
+        <p:nvPicPr>
+          <p:cNvPr id="32" name="Model" descr="TailDaam dashboard screenshot: Model"/>
+          <p:cNvPicPr>
+            <a:picLocks noChangeAspect="1"/>
+          </p:cNvPicPr>
+          <p:nvPr/>
+        </p:nvPicPr>
+        <p:blipFill>
+          <a:blip r:embed="rId4"/>
+          <a:stretch>
+            <a:fillRect/>
+          </a:stretch>
+        </p:blipFill>
         <p:spPr>
           <a:xfrm>
             <a:off x="5577840" y="1188720"/>
@@ -5757,77 +6085,66 @@
               <a:gd name="adj" fmla="val 6667"/>
             </a:avLst>
           </a:prstGeom>
-          <a:solidFill>
-            <a:schemeClr val="bg2"/>
-          </a:solidFill>
           <a:ln w="19050">
             <a:solidFill>
               <a:schemeClr val="accent1"/>
             </a:solidFill>
-            <a:prstDash val="dash"/>
           </a:ln>
         </p:spPr>
-        <p:txBody>
-          <a:bodyPr/>
-          <a:p/>
-        </p:txBody>
-      </p:sp>
-      <p:sp>
-        <p:nvSpPr>
-          <p:cNvPr id="7" name="Text 5"/>
-          <p:cNvSpPr txBox="1"/>
-          <p:nvPr/>
-        </p:nvSpPr>
-        <p:spPr>
-          <a:xfrm>
-            <a:off x="5577840" y="1554480"/>
-            <a:ext cx="3108960" cy="320040"/>
-          </a:xfrm>
-          <a:prstGeom prst="rect">
-            <a:avLst/>
-          </a:prstGeom>
-          <a:noFill/>
-          <a:ln/>
-        </p:spPr>
-        <p:txBody>
-          <a:bodyPr wrap="square" lIns="0" tIns="0" rIns="0" bIns="0" rtlCol="0" anchor="ctr"/>
-          <a:lstStyle/>
-          <a:p>
-            <a:r>
-              <a:t>Page 2 - Model</a:t>
-            </a:r>
-          </a:p>
-        </p:txBody>
-      </p:sp>
-      <p:sp>
-        <p:nvSpPr>
-          <p:cNvPr id="8" name="Text 6"/>
-          <p:cNvSpPr txBox="1"/>
-          <p:nvPr/>
-        </p:nvSpPr>
-        <p:spPr>
-          <a:xfrm>
-            <a:off x="5577840" y="1920240"/>
-            <a:ext cx="3108960" cy="274320"/>
-          </a:xfrm>
-          <a:prstGeom prst="rect">
-            <a:avLst/>
-          </a:prstGeom>
-          <a:noFill/>
-          <a:ln/>
-        </p:spPr>
-        <p:txBody>
-          <a:bodyPr wrap="square" lIns="0" tIns="0" rIns="0" bIns="0" rtlCol="0" anchor="ctr"/>
-          <a:lstStyle/>
-          <a:p/>
-        </p:txBody>
-      </p:sp>
-      <p:sp>
-        <p:nvSpPr>
-          <p:cNvPr id="9" name="Screenshot 3"/>
+      </p:pic>
+      <p:sp>
+        <p:nvSpPr>
+          <p:cNvPr id="33" name="Caption 33"/>
           <p:cNvSpPr/>
           <p:nvPr/>
         </p:nvSpPr>
+        <p:spPr>
+          <a:xfrm>
+            <a:off x="5687568" y="2176272"/>
+            <a:ext cx="1463040" cy="274320"/>
+          </a:xfrm>
+          <a:prstGeom prst="roundRect">
+            <a:avLst>
+              <a:gd name="adj" fmla="val 30000"/>
+            </a:avLst>
+          </a:prstGeom>
+          <a:solidFill>
+            <a:schemeClr val="tx2"/>
+          </a:solidFill>
+          <a:ln>
+            <a:noFill/>
+          </a:ln>
+        </p:spPr>
+        <p:txBody>
+          <a:bodyPr wrap="square" lIns="91440" tIns="0" rIns="91440" bIns="0" rtlCol="0" anchor="ctr"/>
+          <a:lstStyle/>
+          <a:p>
+            <a:pPr algn="ctr"/>
+            <a:r>
+              <a:rPr lang="en-US" sz="1200" b="1" dirty="0">
+                <a:solidFill>
+                  <a:schemeClr val="bg1"/>
+                </a:solidFill>
+              </a:rPr>
+              <a:t>Page 2: Model</a:t>
+            </a:r>
+          </a:p>
+        </p:txBody>
+      </p:sp>
+      <p:pic>
+        <p:nvPicPr>
+          <p:cNvPr id="34" name="Insight agent" descr="TailDaam dashboard screenshot: Insight agent"/>
+          <p:cNvPicPr>
+            <a:picLocks noChangeAspect="1"/>
+          </p:cNvPicPr>
+          <p:nvPr/>
+        </p:nvPicPr>
+        <p:blipFill>
+          <a:blip r:embed="rId5"/>
+          <a:stretch>
+            <a:fillRect/>
+          </a:stretch>
+        </p:blipFill>
         <p:spPr>
           <a:xfrm>
             <a:off x="5577840" y="2743200"/>
@@ -5838,69 +6155,50 @@
               <a:gd name="adj" fmla="val 6667"/>
             </a:avLst>
           </a:prstGeom>
-          <a:solidFill>
-            <a:schemeClr val="bg2"/>
-          </a:solidFill>
           <a:ln w="19050">
             <a:solidFill>
               <a:schemeClr val="accent1"/>
             </a:solidFill>
-            <a:prstDash val="dash"/>
           </a:ln>
         </p:spPr>
-        <p:txBody>
-          <a:bodyPr/>
-          <a:p/>
-        </p:txBody>
-      </p:sp>
-      <p:sp>
-        <p:nvSpPr>
-          <p:cNvPr id="10" name="Text 8"/>
-          <p:cNvSpPr txBox="1"/>
-          <p:nvPr/>
-        </p:nvSpPr>
-        <p:spPr>
-          <a:xfrm>
-            <a:off x="5577840" y="3108960"/>
-            <a:ext cx="3108960" cy="320040"/>
-          </a:xfrm>
-          <a:prstGeom prst="rect">
-            <a:avLst/>
-          </a:prstGeom>
-          <a:noFill/>
-          <a:ln/>
-        </p:spPr>
-        <p:txBody>
-          <a:bodyPr wrap="square" lIns="0" tIns="0" rIns="0" bIns="0" rtlCol="0" anchor="ctr"/>
-          <a:lstStyle/>
-          <a:p>
-            <a:r>
-              <a:t>Page 3 - Insight agent</a:t>
-            </a:r>
-          </a:p>
-        </p:txBody>
-      </p:sp>
-      <p:sp>
-        <p:nvSpPr>
-          <p:cNvPr id="11" name="Text 9"/>
-          <p:cNvSpPr txBox="1"/>
-          <p:nvPr/>
-        </p:nvSpPr>
-        <p:spPr>
-          <a:xfrm>
-            <a:off x="5577840" y="3474720"/>
-            <a:ext cx="3108960" cy="274320"/>
-          </a:xfrm>
-          <a:prstGeom prst="rect">
-            <a:avLst/>
-          </a:prstGeom>
-          <a:noFill/>
-          <a:ln/>
-        </p:spPr>
-        <p:txBody>
-          <a:bodyPr wrap="square" lIns="0" tIns="0" rIns="0" bIns="0" rtlCol="0" anchor="ctr"/>
-          <a:lstStyle/>
-          <a:p/>
+      </p:pic>
+      <p:sp>
+        <p:nvSpPr>
+          <p:cNvPr id="35" name="Caption 35"/>
+          <p:cNvSpPr/>
+          <p:nvPr/>
+        </p:nvSpPr>
+        <p:spPr>
+          <a:xfrm>
+            <a:off x="5687568" y="3730752"/>
+            <a:ext cx="1920240" cy="274320"/>
+          </a:xfrm>
+          <a:prstGeom prst="roundRect">
+            <a:avLst>
+              <a:gd name="adj" fmla="val 30000"/>
+            </a:avLst>
+          </a:prstGeom>
+          <a:solidFill>
+            <a:schemeClr val="tx2"/>
+          </a:solidFill>
+          <a:ln>
+            <a:noFill/>
+          </a:ln>
+        </p:spPr>
+        <p:txBody>
+          <a:bodyPr wrap="square" lIns="91440" tIns="0" rIns="91440" bIns="0" rtlCol="0" anchor="ctr"/>
+          <a:lstStyle/>
+          <a:p>
+            <a:pPr algn="ctr"/>
+            <a:r>
+              <a:rPr lang="en-US" sz="1200" b="1" dirty="0">
+                <a:solidFill>
+                  <a:schemeClr val="bg1"/>
+                </a:solidFill>
+              </a:rPr>
+              <a:t>Page 3: Insight agent</a:t>
+            </a:r>
+          </a:p>
         </p:txBody>
       </p:sp>
       <p:sp>
@@ -5924,9 +6222,18 @@
           <a:bodyPr wrap="square" lIns="0" tIns="0" rIns="0" bIns="0" rtlCol="0" anchor="ctr"/>
           <a:lstStyle/>
           <a:p>
-            <a:r>
-              <a:t>Live: https://danyalabbas-hack-insight.static.hf.space | Repo: https://github.com/DanyalAbbas/hack-insight</a:t>
-            </a:r>
+            <a:pPr indent="0" marL="0">
+              <a:buNone/>
+            </a:pPr>
+            <a:r>
+              <a:rPr lang="en-US" sz="1200" dirty="0">
+                <a:solidFill>
+                  <a:schemeClr val="accent6"/>
+                </a:solidFill>
+              </a:rPr>
+              <a:t>Live: danyalabbas-hack-insight.static.hf.space   |   Repo: github.com/DanyalAbbas/hack-insight</a:t>
+            </a:r>
+            <a:endParaRPr lang="en-US" sz="1200" dirty="0"/>
           </a:p>
         </p:txBody>
       </p:sp>
@@ -5975,78 +6282,6 @@
           </a:p>
         </p:txBody>
       </p:sp>
-      <p:pic>
-        <p:nvPicPr>
-          <p:cNvPr id="26" name="Picture 25" descr="frontend_overview.png"/>
-          <p:cNvPicPr>
-            <a:picLocks noChangeAspect="1"/>
-          </p:cNvPicPr>
-          <p:nvPr/>
-        </p:nvPicPr>
-        <p:blipFill>
-          <a:blip r:embed="rId3"/>
-          <a:stretch>
-            <a:fillRect/>
-          </a:stretch>
-        </p:blipFill>
-        <p:spPr>
-          <a:xfrm>
-            <a:off x="457200" y="1188720"/>
-            <a:ext cx="4937760" cy="2926080"/>
-          </a:xfrm>
-          <a:prstGeom prst="rect">
-            <a:avLst/>
-          </a:prstGeom>
-        </p:spPr>
-      </p:pic>
-      <p:pic>
-        <p:nvPicPr>
-          <p:cNvPr id="27" name="Picture 26" descr="frontend_model.png"/>
-          <p:cNvPicPr>
-            <a:picLocks noChangeAspect="1"/>
-          </p:cNvPicPr>
-          <p:nvPr/>
-        </p:nvPicPr>
-        <p:blipFill>
-          <a:blip r:embed="rId4"/>
-          <a:stretch>
-            <a:fillRect/>
-          </a:stretch>
-        </p:blipFill>
-        <p:spPr>
-          <a:xfrm>
-            <a:off x="5577840" y="1188720"/>
-            <a:ext cx="3108960" cy="1371600"/>
-          </a:xfrm>
-          <a:prstGeom prst="rect">
-            <a:avLst/>
-          </a:prstGeom>
-        </p:spPr>
-      </p:pic>
-      <p:pic>
-        <p:nvPicPr>
-          <p:cNvPr id="28" name="Picture 27" descr="frontend_agent.png"/>
-          <p:cNvPicPr>
-            <a:picLocks noChangeAspect="1"/>
-          </p:cNvPicPr>
-          <p:nvPr/>
-        </p:nvPicPr>
-        <p:blipFill>
-          <a:blip r:embed="rId5"/>
-          <a:stretch>
-            <a:fillRect/>
-          </a:stretch>
-        </p:blipFill>
-        <p:spPr>
-          <a:xfrm>
-            <a:off x="5577840" y="2743200"/>
-            <a:ext cx="3108960" cy="1371600"/>
-          </a:xfrm>
-          <a:prstGeom prst="rect">
-            <a:avLst/>
-          </a:prstGeom>
-        </p:spPr>
-      </p:pic>
     </p:spTree>
   </p:cSld>
   <p:clrMapOvr>
@@ -6095,9 +6330,18 @@
           <a:bodyPr wrap="square" lIns="0" tIns="0" rIns="0" bIns="0" rtlCol="0" anchor="ctr"/>
           <a:lstStyle/>
           <a:p>
-            <a:r>
+            <a:pPr algn="l" indent="0" marL="0">
+              <a:buNone/>
+            </a:pPr>
+            <a:r>
+              <a:rPr lang="en-US" sz="3200" b="1" dirty="0">
+                <a:solidFill>
+                  <a:schemeClr val="tx2"/>
+                </a:solidFill>
+              </a:rPr>
               <a:t>Conclusion</a:t>
             </a:r>
+            <a:endParaRPr lang="en-US" sz="3200" dirty="0"/>
           </a:p>
         </p:txBody>
       </p:sp>
@@ -6122,10 +6366,6 @@
           </a:solidFill>
           <a:ln/>
         </p:spPr>
-        <p:txBody>
-          <a:bodyPr/>
-          <a:p/>
-        </p:txBody>
       </p:sp>
       <p:sp>
         <p:nvSpPr>
@@ -6186,9 +6426,18 @@
           <a:bodyPr wrap="square" lIns="0" tIns="0" rIns="0" bIns="0" rtlCol="0" anchor="ctr"/>
           <a:lstStyle/>
           <a:p>
-            <a:r>
-              <a:t>Model beats persistence by 7.269% MAE</a:t>
-            </a:r>
+            <a:pPr indent="0" marL="0">
+              <a:buNone/>
+            </a:pPr>
+            <a:r>
+              <a:rPr lang="en-US" sz="1400" b="1" dirty="0">
+                <a:solidFill>
+                  <a:schemeClr val="tx2"/>
+                </a:solidFill>
+              </a:rPr>
+              <a:t>Beats the baseline</a:t>
+            </a:r>
+            <a:endParaRPr lang="en-US" sz="1400" dirty="0"/>
           </a:p>
         </p:txBody>
       </p:sp>
@@ -6213,9 +6462,18 @@
           <a:bodyPr wrap="square" lIns="0" tIns="0" rIns="0" bIns="0" rtlCol="0" anchor="ctr"/>
           <a:lstStyle/>
           <a:p>
-            <a:r>
-              <a:t>MAE 17.8044 -&gt; 16.5102; 89.25% interval coverage.</a:t>
-            </a:r>
+            <a:pPr indent="0" marL="0">
+              <a:buNone/>
+            </a:pPr>
+            <a:r>
+              <a:rPr lang="en-US" sz="1200" dirty="0">
+                <a:solidFill>
+                  <a:schemeClr val="accent6"/>
+                </a:solidFill>
+              </a:rPr>
+              <a:t>7.27% lower MAE than persistence (16.51 vs 17.80) on 93 held-out months</a:t>
+            </a:r>
+            <a:endParaRPr lang="en-US" sz="1200" dirty="0"/>
           </a:p>
         </p:txBody>
       </p:sp>
@@ -6240,10 +6498,6 @@
           </a:solidFill>
           <a:ln/>
         </p:spPr>
-        <p:txBody>
-          <a:bodyPr/>
-          <a:p/>
-        </p:txBody>
       </p:sp>
       <p:sp>
         <p:nvSpPr>
@@ -6304,9 +6558,18 @@
           <a:bodyPr wrap="square" lIns="0" tIns="0" rIns="0" bIns="0" rtlCol="0" anchor="ctr"/>
           <a:lstStyle/>
           <a:p>
-            <a:r>
-              <a:t>Agent refuses unsupported questions</a:t>
-            </a:r>
+            <a:pPr indent="0" marL="0">
+              <a:buNone/>
+            </a:pPr>
+            <a:r>
+              <a:rPr lang="en-US" sz="1400" b="1" dirty="0">
+                <a:solidFill>
+                  <a:schemeClr val="tx2"/>
+                </a:solidFill>
+              </a:rPr>
+              <a:t>Honest intervals</a:t>
+            </a:r>
+            <a:endParaRPr lang="en-US" sz="1400" dirty="0"/>
           </a:p>
         </p:txBody>
       </p:sp>
@@ -6331,9 +6594,18 @@
           <a:bodyPr wrap="square" lIns="0" tIns="0" rIns="0" bIns="0" rtlCol="0" anchor="ctr"/>
           <a:lstStyle/>
           <a:p>
-            <a:r>
-              <a:t>Cited answers with row IDs; weather and unsupported periods are refused.</a:t>
-            </a:r>
+            <a:pPr indent="0" marL="0">
+              <a:buNone/>
+            </a:pPr>
+            <a:r>
+              <a:rPr lang="en-US" sz="1200" dirty="0">
+                <a:solidFill>
+                  <a:schemeClr val="accent6"/>
+                </a:solidFill>
+              </a:rPr>
+              <a:t>90% prediction interval covers 89.25% of held-out months</a:t>
+            </a:r>
+            <a:endParaRPr lang="en-US" sz="1200" dirty="0"/>
           </a:p>
         </p:txBody>
       </p:sp>
@@ -6358,10 +6630,6 @@
           </a:solidFill>
           <a:ln/>
         </p:spPr>
-        <p:txBody>
-          <a:bodyPr/>
-          <a:p/>
-        </p:txBody>
       </p:sp>
       <p:sp>
         <p:nvSpPr>
@@ -6422,9 +6690,18 @@
           <a:bodyPr wrap="square" lIns="0" tIns="0" rIns="0" bIns="0" rtlCol="0" anchor="ctr"/>
           <a:lstStyle/>
           <a:p>
-            <a:r>
-              <a:t>Quality status WARN: 14 rules, 1 fix, 4 flags</a:t>
-            </a:r>
+            <a:pPr indent="0" marL="0">
+              <a:buNone/>
+            </a:pPr>
+            <a:r>
+              <a:rPr lang="en-US" sz="1400" b="1" dirty="0">
+                <a:solidFill>
+                  <a:schemeClr val="tx2"/>
+                </a:solidFill>
+              </a:rPr>
+              <a:t>An agent that can say no</a:t>
+            </a:r>
+            <a:endParaRPr lang="en-US" sz="1400" dirty="0"/>
           </a:p>
         </p:txBody>
       </p:sp>
@@ -6449,9 +6726,18 @@
           <a:bodyPr wrap="square" lIns="0" tIns="0" rIns="0" bIns="0" rtlCol="0" anchor="ctr"/>
           <a:lstStyle/>
           <a:p>
-            <a:r>
-              <a:t>No backfilled runs; weekly gaps and the April 2026 HSD outlier are flagged.</a:t>
-            </a:r>
+            <a:pPr indent="0" marL="0">
+              <a:buNone/>
+            </a:pPr>
+            <a:r>
+              <a:rPr lang="en-US" sz="1200" dirty="0">
+                <a:solidFill>
+                  <a:schemeClr val="accent6"/>
+                </a:solidFill>
+              </a:rPr>
+              <a:t>Every number cites a row id; unsupported questions are refused</a:t>
+            </a:r>
+            <a:endParaRPr lang="en-US" sz="1200" dirty="0"/>
           </a:p>
         </p:txBody>
       </p:sp>
@@ -6476,10 +6762,6 @@
           </a:solidFill>
           <a:ln/>
         </p:spPr>
-        <p:txBody>
-          <a:bodyPr/>
-          <a:p/>
-        </p:txBody>
       </p:sp>
       <p:sp>
         <p:nvSpPr>
@@ -6538,9 +6820,18 @@
           <a:bodyPr wrap="square" lIns="0" tIns="0" rIns="0" bIns="0" rtlCol="0" anchor="t"/>
           <a:lstStyle/>
           <a:p>
-            <a:r>
-              <a:t>Journalists, analysts and policymakers get traceable fuel-price evidence.</a:t>
-            </a:r>
+            <a:pPr indent="0" marL="0">
+              <a:buNone/>
+            </a:pPr>
+            <a:r>
+              <a:rPr lang="en-US" sz="1400" dirty="0">
+                <a:solidFill>
+                  <a:schemeClr val="bg1"/>
+                </a:solidFill>
+              </a:rPr>
+              <a:t>Journalists, analysts and fleets verify a price in seconds</a:t>
+            </a:r>
+            <a:endParaRPr lang="en-US" sz="1400" dirty="0"/>
           </a:p>
         </p:txBody>
       </p:sp>
@@ -6565,10 +6856,6 @@
           </a:solidFill>
           <a:ln/>
         </p:spPr>
-        <p:txBody>
-          <a:bodyPr/>
-          <a:p/>
-        </p:txBody>
       </p:sp>
       <p:sp>
         <p:nvSpPr>
@@ -6627,9 +6914,18 @@
           <a:bodyPr wrap="square" lIns="0" tIns="0" rIns="0" bIns="0" rtlCol="0" anchor="t"/>
           <a:lstStyle/>
           <a:p>
-            <a:r>
-              <a:t>OGRA city prices, more monthly annexes, semantic retrieval, reliability monitoring.</a:t>
-            </a:r>
+            <a:pPr indent="0" marL="0">
+              <a:buNone/>
+            </a:pPr>
+            <a:r>
+              <a:rPr lang="en-US" sz="1400" dirty="0">
+                <a:solidFill>
+                  <a:schemeClr val="tx1"/>
+                </a:solidFill>
+              </a:rPr>
+              <a:t>Longer PBS history; domestic price model; live OGRA feed</a:t>
+            </a:r>
+            <a:endParaRPr lang="en-US" sz="1400" dirty="0"/>
           </a:p>
         </p:txBody>
       </p:sp>
@@ -6726,9 +7022,18 @@
           <a:bodyPr wrap="square" lIns="0" tIns="0" rIns="0" bIns="0" rtlCol="0" anchor="ctr"/>
           <a:lstStyle/>
           <a:p>
-            <a:r>
+            <a:pPr algn="l" indent="0" marL="0">
+              <a:buNone/>
+            </a:pPr>
+            <a:r>
+              <a:rPr lang="en-US" sz="3200" b="1" dirty="0">
+                <a:solidFill>
+                  <a:schemeClr val="bg1"/>
+                </a:solidFill>
+              </a:rPr>
               <a:t>Team &amp; Credits</a:t>
             </a:r>
+            <a:endParaRPr lang="en-US" sz="3200" dirty="0"/>
           </a:p>
         </p:txBody>
       </p:sp>
@@ -6753,9 +7058,18 @@
           <a:bodyPr wrap="square" lIns="0" tIns="0" rIns="0" bIns="0" rtlCol="0" anchor="ctr"/>
           <a:lstStyle/>
           <a:p>
-            <a:r>
-              <a:t>TailDaam</a:t>
-            </a:r>
+            <a:pPr indent="0" marL="0">
+              <a:buNone/>
+            </a:pPr>
+            <a:r>
+              <a:rPr lang="en-US" sz="2800" b="1" dirty="0">
+                <a:solidFill>
+                  <a:schemeClr val="accent4"/>
+                </a:solidFill>
+              </a:rPr>
+              <a:t>TAILDAAM</a:t>
+            </a:r>
+            <a:endParaRPr lang="en-US" sz="2800" dirty="0"/>
           </a:p>
         </p:txBody>
       </p:sp>
@@ -6767,8 +7081,8 @@
         </p:nvSpPr>
         <p:spPr>
           <a:xfrm>
-            <a:off x="457200" y="1828800"/>
-            <a:ext cx="1920240" cy="1783080"/>
+            <a:off x="3200400" y="1828800"/>
+            <a:ext cx="2743200" cy="1783080"/>
           </a:xfrm>
           <a:prstGeom prst="roundRect">
             <a:avLst>
@@ -6782,10 +7096,6 @@
           </a:solidFill>
           <a:ln/>
         </p:spPr>
-        <p:txBody>
-          <a:bodyPr/>
-          <a:p/>
-        </p:txBody>
       </p:sp>
       <p:sp>
         <p:nvSpPr>
@@ -6795,7 +7105,7 @@
         </p:nvSpPr>
         <p:spPr>
           <a:xfrm>
-            <a:off x="1097280" y="2011680"/>
+            <a:off x="4251960" y="2011680"/>
             <a:ext cx="640080" cy="640080"/>
           </a:xfrm>
           <a:prstGeom prst="ellipse">
@@ -6819,7 +7129,7 @@
                   <a:schemeClr val="bg1"/>
                 </a:solidFill>
               </a:rPr>
-              <a:t>AB</a:t>
+              <a:t>DA</a:t>
             </a:r>
             <a:endParaRPr lang="en-US" sz="1600" dirty="0"/>
           </a:p>
@@ -6833,97 +7143,13 @@
         </p:nvSpPr>
         <p:spPr>
           <a:xfrm>
-            <a:off x="548640" y="2788920"/>
-            <a:ext cx="1737360" cy="274320"/>
+            <a:off x="3291840" y="2788920"/>
+            <a:ext cx="2560320" cy="274320"/>
           </a:xfrm>
           <a:prstGeom prst="rect">
             <a:avLst/>
           </a:prstGeom>
           <a:noFill/>
-          <a:ln/>
-        </p:spPr>
-        <p:txBody>
-          <a:bodyPr wrap="square" lIns="0" tIns="0" rIns="0" bIns="0" rtlCol="0" anchor="ctr"/>
-          <a:lstStyle/>
-          <a:p>
-            <a:r>
-              <a:t>Danyal Abbas</a:t>
-            </a:r>
-          </a:p>
-        </p:txBody>
-      </p:sp>
-      <p:sp>
-        <p:nvSpPr>
-          <p:cNvPr id="7" name="Text 5"/>
-          <p:cNvSpPr txBox="1"/>
-          <p:nvPr/>
-        </p:nvSpPr>
-        <p:spPr>
-          <a:xfrm>
-            <a:off x="548640" y="3108960"/>
-            <a:ext cx="1737360" cy="274320"/>
-          </a:xfrm>
-          <a:prstGeom prst="rect">
-            <a:avLst/>
-          </a:prstGeom>
-          <a:noFill/>
-          <a:ln/>
-        </p:spPr>
-        <p:txBody>
-          <a:bodyPr wrap="square" lIns="0" tIns="0" rIns="0" bIns="0" rtlCol="0" anchor="ctr"/>
-          <a:lstStyle/>
-          <a:p>
-            <a:r>
-              <a:t>Data, model, agent, pipeline, deployment</a:t>
-            </a:r>
-          </a:p>
-        </p:txBody>
-      </p:sp>
-      <p:sp>
-        <p:nvSpPr>
-          <p:cNvPr id="8" name="Member card 2"/>
-          <p:cNvSpPr/>
-          <p:nvPr/>
-        </p:nvSpPr>
-        <p:spPr>
-          <a:xfrm>
-            <a:off x="2560320" y="1828800"/>
-            <a:ext cx="1920240" cy="1783080"/>
-          </a:xfrm>
-          <a:prstGeom prst="roundRect">
-            <a:avLst>
-              <a:gd name="adj" fmla="val 5128"/>
-            </a:avLst>
-          </a:prstGeom>
-          <a:solidFill>
-            <a:schemeClr val="bg1">
-              <a:alpha val="12000"/>
-            </a:schemeClr>
-          </a:solidFill>
-          <a:ln/>
-        </p:spPr>
-        <p:txBody>
-          <a:bodyPr/>
-          <a:p/>
-        </p:txBody>
-      </p:sp>
-      <p:sp>
-        <p:nvSpPr>
-          <p:cNvPr id="9" name="Avatar 2"/>
-          <p:cNvSpPr txBox="1"/>
-          <p:nvPr/>
-        </p:nvSpPr>
-        <p:spPr>
-          <a:xfrm>
-            <a:off x="3200400" y="2011680"/>
-            <a:ext cx="640080" cy="640080"/>
-          </a:xfrm>
-          <a:prstGeom prst="ellipse">
-            <a:avLst/>
-          </a:prstGeom>
-          <a:solidFill>
-            <a:schemeClr val="accent1"/>
-          </a:solidFill>
           <a:ln/>
         </p:spPr>
         <p:txBody>
@@ -6934,116 +7160,32 @@
               <a:buNone/>
             </a:pPr>
             <a:r>
-              <a:rPr lang="en-US" sz="1600" b="1" dirty="0">
+              <a:rPr lang="en-US" sz="1400" b="1" dirty="0">
                 <a:solidFill>
                   <a:schemeClr val="bg1"/>
                 </a:solidFill>
               </a:rPr>
-              <a:t>AB</a:t>
-            </a:r>
-            <a:endParaRPr lang="en-US" sz="1600" dirty="0"/>
-          </a:p>
-        </p:txBody>
-      </p:sp>
-      <p:sp>
-        <p:nvSpPr>
-          <p:cNvPr id="10" name="Text 8"/>
+              <a:t>Danyal Abbas</a:t>
+            </a:r>
+            <a:endParaRPr lang="en-US" sz="1400" dirty="0"/>
+          </a:p>
+        </p:txBody>
+      </p:sp>
+      <p:sp>
+        <p:nvSpPr>
+          <p:cNvPr id="7" name="Text 5"/>
           <p:cNvSpPr txBox="1"/>
           <p:nvPr/>
         </p:nvSpPr>
         <p:spPr>
           <a:xfrm>
-            <a:off x="2651760" y="2788920"/>
-            <a:ext cx="1737360" cy="274320"/>
+            <a:off x="3291840" y="3108960"/>
+            <a:ext cx="2560320" cy="274320"/>
           </a:xfrm>
           <a:prstGeom prst="rect">
             <a:avLst/>
           </a:prstGeom>
           <a:noFill/>
-          <a:ln/>
-        </p:spPr>
-        <p:txBody>
-          <a:bodyPr wrap="square" lIns="0" tIns="0" rIns="0" bIns="0" rtlCol="0" anchor="ctr"/>
-          <a:lstStyle/>
-          <a:p>
-            <a:r>
-              <a:t>Open contributor slot</a:t>
-            </a:r>
-          </a:p>
-        </p:txBody>
-      </p:sp>
-      <p:sp>
-        <p:nvSpPr>
-          <p:cNvPr id="11" name="Text 9"/>
-          <p:cNvSpPr txBox="1"/>
-          <p:nvPr/>
-        </p:nvSpPr>
-        <p:spPr>
-          <a:xfrm>
-            <a:off x="2651760" y="3108960"/>
-            <a:ext cx="1737360" cy="274320"/>
-          </a:xfrm>
-          <a:prstGeom prst="rect">
-            <a:avLst/>
-          </a:prstGeom>
-          <a:noFill/>
-          <a:ln/>
-        </p:spPr>
-        <p:txBody>
-          <a:bodyPr wrap="square" lIns="0" tIns="0" rIns="0" bIns="0" rtlCol="0" anchor="ctr"/>
-          <a:lstStyle/>
-          <a:p>
-            <a:r>
-              <a:t>Reserved for hackathon team</a:t>
-            </a:r>
-          </a:p>
-        </p:txBody>
-      </p:sp>
-      <p:sp>
-        <p:nvSpPr>
-          <p:cNvPr id="12" name="Member card 3"/>
-          <p:cNvSpPr/>
-          <p:nvPr/>
-        </p:nvSpPr>
-        <p:spPr>
-          <a:xfrm>
-            <a:off x="4663440" y="1828800"/>
-            <a:ext cx="1920240" cy="1783080"/>
-          </a:xfrm>
-          <a:prstGeom prst="roundRect">
-            <a:avLst>
-              <a:gd name="adj" fmla="val 5128"/>
-            </a:avLst>
-          </a:prstGeom>
-          <a:solidFill>
-            <a:schemeClr val="bg1">
-              <a:alpha val="12000"/>
-            </a:schemeClr>
-          </a:solidFill>
-          <a:ln/>
-        </p:spPr>
-        <p:txBody>
-          <a:bodyPr/>
-          <a:p/>
-        </p:txBody>
-      </p:sp>
-      <p:sp>
-        <p:nvSpPr>
-          <p:cNvPr id="13" name="Avatar 3"/>
-          <p:cNvSpPr txBox="1"/>
-          <p:nvPr/>
-        </p:nvSpPr>
-        <p:spPr>
-          <a:xfrm>
-            <a:off x="5303520" y="2011680"/>
-            <a:ext cx="640080" cy="640080"/>
-          </a:xfrm>
-          <a:prstGeom prst="ellipse">
-            <a:avLst/>
-          </a:prstGeom>
-          <a:solidFill>
-            <a:schemeClr val="accent1"/>
-          </a:solidFill>
           <a:ln/>
         </p:spPr>
         <p:txBody>
@@ -7054,27 +7196,27 @@
               <a:buNone/>
             </a:pPr>
             <a:r>
-              <a:rPr lang="en-US" sz="1600" b="1" dirty="0">
-                <a:solidFill>
-                  <a:schemeClr val="bg1"/>
+              <a:rPr lang="en-US" sz="1200" dirty="0">
+                <a:solidFill>
+                  <a:schemeClr val="accent4"/>
                 </a:solidFill>
               </a:rPr>
-              <a:t>AB</a:t>
-            </a:r>
-            <a:endParaRPr lang="en-US" sz="1600" dirty="0"/>
-          </a:p>
-        </p:txBody>
-      </p:sp>
-      <p:sp>
-        <p:nvSpPr>
-          <p:cNvPr id="14" name="Text 12"/>
+              <a:t>Data, model, agent, app, deploy</a:t>
+            </a:r>
+            <a:endParaRPr lang="en-US" sz="1200" dirty="0"/>
+          </a:p>
+        </p:txBody>
+      </p:sp>
+      <p:sp>
+        <p:nvSpPr>
+          <p:cNvPr id="20" name="Text 18"/>
           <p:cNvSpPr txBox="1"/>
           <p:nvPr/>
         </p:nvSpPr>
         <p:spPr>
           <a:xfrm>
-            <a:off x="4754880" y="2788920"/>
-            <a:ext cx="1737360" cy="274320"/>
+            <a:off x="457200" y="3931920"/>
+            <a:ext cx="8229600" cy="274320"/>
           </a:xfrm>
           <a:prstGeom prst="rect">
             <a:avLst/>
@@ -7086,183 +7228,18 @@
           <a:bodyPr wrap="square" lIns="0" tIns="0" rIns="0" bIns="0" rtlCol="0" anchor="ctr"/>
           <a:lstStyle/>
           <a:p>
-            <a:r>
-              <a:t>Open contributor slot</a:t>
-            </a:r>
-          </a:p>
-        </p:txBody>
-      </p:sp>
-      <p:sp>
-        <p:nvSpPr>
-          <p:cNvPr id="15" name="Text 13"/>
-          <p:cNvSpPr txBox="1"/>
-          <p:nvPr/>
-        </p:nvSpPr>
-        <p:spPr>
-          <a:xfrm>
-            <a:off x="4754880" y="3108960"/>
-            <a:ext cx="1737360" cy="274320"/>
-          </a:xfrm>
-          <a:prstGeom prst="rect">
-            <a:avLst/>
-          </a:prstGeom>
-          <a:noFill/>
-          <a:ln/>
-        </p:spPr>
-        <p:txBody>
-          <a:bodyPr wrap="square" lIns="0" tIns="0" rIns="0" bIns="0" rtlCol="0" anchor="ctr"/>
-          <a:lstStyle/>
-          <a:p>
-            <a:r>
-              <a:t>Reserved for hackathon team</a:t>
-            </a:r>
-          </a:p>
-        </p:txBody>
-      </p:sp>
-      <p:sp>
-        <p:nvSpPr>
-          <p:cNvPr id="16" name="Member card 4"/>
-          <p:cNvSpPr/>
-          <p:nvPr/>
-        </p:nvSpPr>
-        <p:spPr>
-          <a:xfrm>
-            <a:off x="6766560" y="1828800"/>
-            <a:ext cx="1920240" cy="1783080"/>
-          </a:xfrm>
-          <a:prstGeom prst="roundRect">
-            <a:avLst>
-              <a:gd name="adj" fmla="val 5128"/>
-            </a:avLst>
-          </a:prstGeom>
-          <a:solidFill>
-            <a:schemeClr val="bg1">
-              <a:alpha val="12000"/>
-            </a:schemeClr>
-          </a:solidFill>
-          <a:ln/>
-        </p:spPr>
-        <p:txBody>
-          <a:bodyPr/>
-          <a:p/>
-        </p:txBody>
-      </p:sp>
-      <p:sp>
-        <p:nvSpPr>
-          <p:cNvPr id="17" name="Avatar 4"/>
-          <p:cNvSpPr txBox="1"/>
-          <p:nvPr/>
-        </p:nvSpPr>
-        <p:spPr>
-          <a:xfrm>
-            <a:off x="7406640" y="2011680"/>
-            <a:ext cx="640080" cy="640080"/>
-          </a:xfrm>
-          <a:prstGeom prst="ellipse">
-            <a:avLst/>
-          </a:prstGeom>
-          <a:solidFill>
-            <a:schemeClr val="accent1"/>
-          </a:solidFill>
-          <a:ln/>
-        </p:spPr>
-        <p:txBody>
-          <a:bodyPr wrap="square" lIns="0" tIns="0" rIns="0" bIns="0" rtlCol="0" anchor="ctr"/>
-          <a:lstStyle/>
-          <a:p>
-            <a:pPr algn="ctr" indent="0" marL="0">
+            <a:pPr indent="0" marL="0">
               <a:buNone/>
             </a:pPr>
             <a:r>
-              <a:rPr lang="en-US" sz="1600" b="1" dirty="0">
+              <a:rPr lang="en-US" sz="1400" dirty="0">
                 <a:solidFill>
                   <a:schemeClr val="bg1"/>
                 </a:solidFill>
               </a:rPr>
-              <a:t>AB</a:t>
-            </a:r>
-            <a:endParaRPr lang="en-US" sz="1600" dirty="0"/>
-          </a:p>
-        </p:txBody>
-      </p:sp>
-      <p:sp>
-        <p:nvSpPr>
-          <p:cNvPr id="18" name="Text 16"/>
-          <p:cNvSpPr txBox="1"/>
-          <p:nvPr/>
-        </p:nvSpPr>
-        <p:spPr>
-          <a:xfrm>
-            <a:off x="6858000" y="2788920"/>
-            <a:ext cx="1737360" cy="274320"/>
-          </a:xfrm>
-          <a:prstGeom prst="rect">
-            <a:avLst/>
-          </a:prstGeom>
-          <a:noFill/>
-          <a:ln/>
-        </p:spPr>
-        <p:txBody>
-          <a:bodyPr wrap="square" lIns="0" tIns="0" rIns="0" bIns="0" rtlCol="0" anchor="ctr"/>
-          <a:lstStyle/>
-          <a:p>
-            <a:r>
-              <a:t>Open contributor slot</a:t>
-            </a:r>
-          </a:p>
-        </p:txBody>
-      </p:sp>
-      <p:sp>
-        <p:nvSpPr>
-          <p:cNvPr id="19" name="Text 17"/>
-          <p:cNvSpPr txBox="1"/>
-          <p:nvPr/>
-        </p:nvSpPr>
-        <p:spPr>
-          <a:xfrm>
-            <a:off x="6858000" y="3108960"/>
-            <a:ext cx="1737360" cy="274320"/>
-          </a:xfrm>
-          <a:prstGeom prst="rect">
-            <a:avLst/>
-          </a:prstGeom>
-          <a:noFill/>
-          <a:ln/>
-        </p:spPr>
-        <p:txBody>
-          <a:bodyPr wrap="square" lIns="0" tIns="0" rIns="0" bIns="0" rtlCol="0" anchor="ctr"/>
-          <a:lstStyle/>
-          <a:p>
-            <a:r>
-              <a:t>Reserved for hackathon team</a:t>
-            </a:r>
-          </a:p>
-        </p:txBody>
-      </p:sp>
-      <p:sp>
-        <p:nvSpPr>
-          <p:cNvPr id="20" name="Text 18"/>
-          <p:cNvSpPr txBox="1"/>
-          <p:nvPr/>
-        </p:nvSpPr>
-        <p:spPr>
-          <a:xfrm>
-            <a:off x="457200" y="3931920"/>
-            <a:ext cx="8229600" cy="274320"/>
-          </a:xfrm>
-          <a:prstGeom prst="rect">
-            <a:avLst/>
-          </a:prstGeom>
-          <a:noFill/>
-          <a:ln/>
-        </p:spPr>
-        <p:txBody>
-          <a:bodyPr wrap="square" lIns="0" tIns="0" rIns="0" bIns="0" rtlCol="0" anchor="ctr"/>
-          <a:lstStyle/>
-          <a:p>
-            <a:r>
-              <a:t>Mentor / Supervisor: none declared  |  Contact: github.com/DanyalAbbas/hack-insight</a:t>
-            </a:r>
+              <a:t>Repo: github.com/DanyalAbbas/hack-insight    |    Live: danyalabbas-hack-insight.static.hf.space</a:t>
+            </a:r>
+            <a:endParaRPr lang="en-US" sz="1400" dirty="0"/>
           </a:p>
         </p:txBody>
       </p:sp>

</xml_diff>